<commit_message>
Group slide four into passage work, proposals and evidence review
</commit_message>
<xml_diff>
--- a/docs/presentation/cohort-pnc-2026-main.pptx
+++ b/docs/presentation/cohort-pnc-2026-main.pptx
@@ -15549,7 +15549,7 @@
               </a:defRPr>
             </a:pPr>
             <a:r>
-              <a:rPr>
+              <a:rPr dirty="0">
                 <a:ea typeface="Microsoft JhengHei"/>
               </a:rPr>
               <a:t>Acknowledgement</a:t>
@@ -15566,7 +15566,7 @@
         <p:spPr>
           <a:xfrm>
             <a:off x="523874" y="1809750"/>
-            <a:ext cx="11049000" cy="523220"/>
+            <a:ext cx="11049000" cy="457882"/>
           </a:xfrm>
           <a:prstGeom prst="rect">
             <a:avLst/>
@@ -15597,24 +15597,24 @@
               </a:defRPr>
             </a:pPr>
             <a:r>
-              <a:rPr lang="en-US" sz="3200" dirty="0">
-                <a:ea typeface="Microsoft JhengHei"/>
-              </a:rPr>
-              <a:t>Data provided by </a:t>
-            </a:r>
-            <a:r>
-              <a:rPr sz="3200" dirty="0">
+              <a:rPr lang="en-US" sz="2800" dirty="0">
+                <a:ea typeface="Microsoft JhengHei"/>
+              </a:rPr>
+              <a:t>Data provided by Prof. </a:t>
+            </a:r>
+            <a:r>
+              <a:rPr sz="2800" dirty="0">
                 <a:ea typeface="Microsoft JhengHei"/>
               </a:rPr>
               <a:t>Michael Radich</a:t>
             </a:r>
             <a:r>
-              <a:rPr lang="en-US" sz="3200" dirty="0">
+              <a:rPr lang="en-US" sz="2800" dirty="0">
                 <a:ea typeface="Microsoft JhengHei"/>
               </a:rPr>
               <a:t> of Heidelberg University</a:t>
             </a:r>
-            <a:endParaRPr sz="3200" dirty="0">
+            <a:endParaRPr sz="2800" dirty="0">
               <a:ea typeface="Microsoft JhengHei"/>
             </a:endParaRPr>
           </a:p>
@@ -16860,7 +16860,7 @@
         <p:spPr>
           <a:xfrm>
             <a:off x="495299" y="742950"/>
-            <a:ext cx="11144250" cy="952500"/>
+            <a:ext cx="11144250" cy="523220"/>
           </a:xfrm>
           <a:prstGeom prst="rect">
             <a:avLst/>
@@ -16891,11 +16891,14 @@
               </a:defRPr>
             </a:pPr>
             <a:r>
-              <a:rPr>
-                <a:ea typeface="Microsoft JhengHei"/>
-              </a:rPr>
-              <a:t>Why we built Cohort</a:t>
-            </a:r>
+              <a:rPr lang="en-US" dirty="0">
+                <a:ea typeface="Microsoft JhengHei"/>
+              </a:rPr>
+              <a:t>Cohort’s purpose</a:t>
+            </a:r>
+            <a:endParaRPr dirty="0">
+              <a:ea typeface="Microsoft JhengHei"/>
+            </a:endParaRPr>
           </a:p>
         </p:txBody>
       </p:sp>
@@ -16908,7 +16911,7 @@
         <p:spPr>
           <a:xfrm>
             <a:off x="523874" y="1952624"/>
-            <a:ext cx="10953750" cy="1238250"/>
+            <a:ext cx="10953750" cy="1104277"/>
           </a:xfrm>
           <a:prstGeom prst="rect">
             <a:avLst/>
@@ -16942,33 +16945,29 @@
               <a:rPr dirty="0">
                 <a:ea typeface="Microsoft JhengHei"/>
               </a:rPr>
-              <a:t>Let researchers direct agents and inspect</a:t>
-            </a:r>
-          </a:p>
-          <a:p>
-            <a:pPr>
-              <a:lnSpc>
-                <a:spcPct val="118000"/>
-              </a:lnSpc>
-              <a:spcBef>
-                <a:spcPts val="0"/>
-              </a:spcBef>
-              <a:spcAft>
-                <a:spcPts val="0"/>
-              </a:spcAft>
-              <a:defRPr sz="3200" b="0">
-                <a:solidFill>
-                  <a:srgbClr val="24384A"/>
-                </a:solidFill>
-                <a:latin typeface="Lato"/>
-              </a:defRPr>
-            </a:pPr>
+              <a:t>Let researchers</a:t>
+            </a:r>
+            <a:r>
+              <a:rPr lang="en-US" dirty="0">
+                <a:ea typeface="Microsoft JhengHei"/>
+              </a:rPr>
+              <a:t> leverage</a:t>
+            </a:r>
             <a:r>
               <a:rPr dirty="0">
                 <a:ea typeface="Microsoft JhengHei"/>
               </a:rPr>
-              <a:t>the evidence behind their proposals.</a:t>
-            </a:r>
+              <a:t> agents </a:t>
+            </a:r>
+            <a:r>
+              <a:rPr lang="en-US" dirty="0">
+                <a:ea typeface="Microsoft JhengHei"/>
+              </a:rPr>
+              <a:t>to explore new possibilities and directions while ensuring data provenance</a:t>
+            </a:r>
+            <a:endParaRPr dirty="0">
+              <a:ea typeface="Microsoft JhengHei"/>
+            </a:endParaRPr>
           </a:p>
         </p:txBody>
       </p:sp>
@@ -17340,8 +17339,8 @@
         </p:nvSpPr>
         <p:spPr>
           <a:xfrm>
-            <a:off x="676275" y="2981325"/>
-            <a:ext cx="2266950" cy="495299"/>
+            <a:off x="666750" y="2857500"/>
+            <a:ext cx="3381375" cy="857250"/>
           </a:xfrm>
           <a:prstGeom prst="rect">
             <a:avLst/>
@@ -17364,7 +17363,7 @@
               <a:spcAft>
                 <a:spcPts val="0"/>
               </a:spcAft>
-              <a:defRPr sz="2000" b="1">
+              <a:defRPr sz="2300" b="1">
                 <a:solidFill>
                   <a:srgbClr val="155F88"/>
                 </a:solidFill>
@@ -17375,7 +17374,32 @@
               <a:rPr>
                 <a:ea typeface="Microsoft JhengHei"/>
               </a:rPr>
-              <a:t>Exact search</a:t>
+              <a:t>Find and compare</a:t>
+            </a:r>
+          </a:p>
+          <a:p>
+            <a:pPr>
+              <a:lnSpc>
+                <a:spcPct val="118000"/>
+              </a:lnSpc>
+              <a:spcBef>
+                <a:spcPts val="0"/>
+              </a:spcBef>
+              <a:spcAft>
+                <a:spcPts val="0"/>
+              </a:spcAft>
+              <a:defRPr sz="2300" b="1">
+                <a:solidFill>
+                  <a:srgbClr val="155F88"/>
+                </a:solidFill>
+                <a:latin typeface="Lato"/>
+              </a:defRPr>
+            </a:pPr>
+            <a:r>
+              <a:rPr>
+                <a:ea typeface="Microsoft JhengHei"/>
+              </a:rPr>
+              <a:t>passages</a:t>
             </a:r>
           </a:p>
         </p:txBody>
@@ -17388,8 +17412,8 @@
         </p:nvSpPr>
         <p:spPr>
           <a:xfrm>
-            <a:off x="676275" y="3657600"/>
-            <a:ext cx="2266950" cy="723900"/>
+            <a:off x="4429125" y="2857500"/>
+            <a:ext cx="7143750" cy="952500"/>
           </a:xfrm>
           <a:prstGeom prst="rect">
             <a:avLst/>
@@ -17412,7 +17436,7 @@
               <a:spcAft>
                 <a:spcPts val="0"/>
               </a:spcAft>
-              <a:defRPr sz="1900" b="0">
+              <a:defRPr sz="2300" b="0">
                 <a:solidFill>
                   <a:srgbClr val="24384A"/>
                 </a:solidFill>
@@ -17423,21 +17447,21 @@
               <a:rPr>
                 <a:ea typeface="Microsoft JhengHei"/>
               </a:rPr>
-              <a:t>Find a phrase</a:t>
-            </a:r>
-          </a:p>
-          <a:p>
-            <a:pPr>
-              <a:lnSpc>
-                <a:spcPct val="118000"/>
-              </a:lnSpc>
-              <a:spcBef>
-                <a:spcPts val="0"/>
-              </a:spcBef>
-              <a:spcAft>
-                <a:spcPts val="0"/>
-              </a:spcAft>
-              <a:defRPr sz="1900" b="0">
+              <a:t>Search exact phrases, retrieve related passages,</a:t>
+            </a:r>
+          </a:p>
+          <a:p>
+            <a:pPr>
+              <a:lnSpc>
+                <a:spcPct val="118000"/>
+              </a:lnSpc>
+              <a:spcBef>
+                <a:spcPts val="0"/>
+              </a:spcBef>
+              <a:spcAft>
+                <a:spcPts val="0"/>
+              </a:spcAft>
+              <a:defRPr sz="2300" b="0">
                 <a:solidFill>
                   <a:srgbClr val="24384A"/>
                 </a:solidFill>
@@ -17448,7 +17472,7 @@
               <a:rPr>
                 <a:ea typeface="Microsoft JhengHei"/>
               </a:rPr>
-              <a:t>and open its source.</a:t>
+              <a:t>and inspect shared wording.</a:t>
             </a:r>
           </a:p>
         </p:txBody>
@@ -17461,8 +17485,8 @@
         </p:nvSpPr>
         <p:spPr>
           <a:xfrm>
-            <a:off x="3533775" y="2981325"/>
-            <a:ext cx="2266950" cy="495299"/>
+            <a:off x="666750" y="4048125"/>
+            <a:ext cx="3381375" cy="857250"/>
           </a:xfrm>
           <a:prstGeom prst="rect">
             <a:avLst/>
@@ -17485,7 +17509,7 @@
               <a:spcAft>
                 <a:spcPts val="0"/>
               </a:spcAft>
-              <a:defRPr sz="2000" b="1">
+              <a:defRPr sz="2300" b="1">
                 <a:solidFill>
                   <a:srgbClr val="155F88"/>
                 </a:solidFill>
@@ -17496,7 +17520,32 @@
               <a:rPr>
                 <a:ea typeface="Microsoft JhengHei"/>
               </a:rPr>
-              <a:t>Related passages</a:t>
+              <a:t>Develop research</a:t>
+            </a:r>
+          </a:p>
+          <a:p>
+            <a:pPr>
+              <a:lnSpc>
+                <a:spcPct val="118000"/>
+              </a:lnSpc>
+              <a:spcBef>
+                <a:spcPts val="0"/>
+              </a:spcBef>
+              <a:spcAft>
+                <a:spcPts val="0"/>
+              </a:spcAft>
+              <a:defRPr sz="2300" b="1">
+                <a:solidFill>
+                  <a:srgbClr val="155F88"/>
+                </a:solidFill>
+                <a:latin typeface="Lato"/>
+              </a:defRPr>
+            </a:pPr>
+            <a:r>
+              <a:rPr>
+                <a:ea typeface="Microsoft JhengHei"/>
+              </a:rPr>
+              <a:t>proposals</a:t>
             </a:r>
           </a:p>
         </p:txBody>
@@ -17509,8 +17558,8 @@
         </p:nvSpPr>
         <p:spPr>
           <a:xfrm>
-            <a:off x="3533775" y="3657600"/>
-            <a:ext cx="2266950" cy="723900"/>
+            <a:off x="4429125" y="4048125"/>
+            <a:ext cx="7143750" cy="952500"/>
           </a:xfrm>
           <a:prstGeom prst="rect">
             <a:avLst/>
@@ -17533,7 +17582,7 @@
               <a:spcAft>
                 <a:spcPts val="0"/>
               </a:spcAft>
-              <a:defRPr sz="1900" b="0">
+              <a:defRPr sz="2300" b="0">
                 <a:solidFill>
                   <a:srgbClr val="24384A"/>
                 </a:solidFill>
@@ -17544,21 +17593,21 @@
               <a:rPr>
                 <a:ea typeface="Microsoft JhengHei"/>
               </a:rPr>
-              <a:t>Retrieve candidates</a:t>
-            </a:r>
-          </a:p>
-          <a:p>
-            <a:pPr>
-              <a:lnSpc>
-                <a:spcPct val="118000"/>
-              </a:lnSpc>
-              <a:spcBef>
-                <a:spcPts val="0"/>
-              </a:spcBef>
-              <a:spcAft>
-                <a:spcPts val="0"/>
-              </a:spcAft>
-              <a:defRPr sz="1900" b="0">
+              <a:t>Suggest explanations, alternatives</a:t>
+            </a:r>
+          </a:p>
+          <a:p>
+            <a:pPr>
+              <a:lnSpc>
+                <a:spcPct val="118000"/>
+              </a:lnSpc>
+              <a:spcBef>
+                <a:spcPts val="0"/>
+              </a:spcBef>
+              <a:spcAft>
+                <a:spcPts val="0"/>
+              </a:spcAft>
+              <a:defRPr sz="2300" b="0">
                 <a:solidFill>
                   <a:srgbClr val="24384A"/>
                 </a:solidFill>
@@ -17569,7 +17618,7 @@
               <a:rPr>
                 <a:ea typeface="Microsoft JhengHei"/>
               </a:rPr>
-              <a:t>using embeddings.</a:t>
+              <a:t>and follow-up searches.</a:t>
             </a:r>
           </a:p>
         </p:txBody>
@@ -17582,8 +17631,8 @@
         </p:nvSpPr>
         <p:spPr>
           <a:xfrm>
-            <a:off x="6391275" y="2981325"/>
-            <a:ext cx="2266950" cy="495299"/>
+            <a:off x="666750" y="5238750"/>
+            <a:ext cx="3381375" cy="857250"/>
           </a:xfrm>
           <a:prstGeom prst="rect">
             <a:avLst/>
@@ -17606,7 +17655,7 @@
               <a:spcAft>
                 <a:spcPts val="0"/>
               </a:spcAft>
-              <a:defRPr sz="2000" b="1">
+              <a:defRPr sz="2300" b="1">
                 <a:solidFill>
                   <a:srgbClr val="80511B"/>
                 </a:solidFill>
@@ -17617,7 +17666,32 @@
               <a:rPr>
                 <a:ea typeface="Microsoft JhengHei"/>
               </a:rPr>
-              <a:t>Shared wording</a:t>
+              <a:t>Inspect sources,</a:t>
+            </a:r>
+          </a:p>
+          <a:p>
+            <a:pPr>
+              <a:lnSpc>
+                <a:spcPct val="118000"/>
+              </a:lnSpc>
+              <a:spcBef>
+                <a:spcPts val="0"/>
+              </a:spcBef>
+              <a:spcAft>
+                <a:spcPts val="0"/>
+              </a:spcAft>
+              <a:defRPr sz="2300" b="1">
+                <a:solidFill>
+                  <a:srgbClr val="80511B"/>
+                </a:solidFill>
+                <a:latin typeface="Lato"/>
+              </a:defRPr>
+            </a:pPr>
+            <a:r>
+              <a:rPr>
+                <a:ea typeface="Microsoft JhengHei"/>
+              </a:rPr>
+              <a:t>checks and decisions</a:t>
             </a:r>
           </a:p>
         </p:txBody>
@@ -17630,8 +17704,8 @@
         </p:nvSpPr>
         <p:spPr>
           <a:xfrm>
-            <a:off x="6391275" y="3657600"/>
-            <a:ext cx="2266950" cy="723900"/>
+            <a:off x="4429125" y="5238750"/>
+            <a:ext cx="7143750" cy="952500"/>
           </a:xfrm>
           <a:prstGeom prst="rect">
             <a:avLst/>
@@ -17654,7 +17728,7 @@
               <a:spcAft>
                 <a:spcPts val="0"/>
               </a:spcAft>
-              <a:defRPr sz="1800" b="0">
+              <a:defRPr sz="2300" b="0">
                 <a:solidFill>
                   <a:srgbClr val="24384A"/>
                 </a:solidFill>
@@ -17665,21 +17739,21 @@
               <a:rPr>
                 <a:ea typeface="Microsoft JhengHei"/>
               </a:rPr>
-              <a:t>Locate matching spans</a:t>
-            </a:r>
-          </a:p>
-          <a:p>
-            <a:pPr>
-              <a:lnSpc>
-                <a:spcPct val="118000"/>
-              </a:lnSpc>
-              <a:spcBef>
-                <a:spcPts val="0"/>
-              </a:spcBef>
-              <a:spcAft>
-                <a:spcPts val="0"/>
-              </a:spcAft>
-              <a:defRPr sz="1800" b="0">
+              <a:t>Trace proposals to evidence.</a:t>
+            </a:r>
+          </a:p>
+          <a:p>
+            <a:pPr>
+              <a:lnSpc>
+                <a:spcPct val="118000"/>
+              </a:lnSpc>
+              <a:spcBef>
+                <a:spcPts val="0"/>
+              </a:spcBef>
+              <a:spcAft>
+                <a:spcPts val="0"/>
+              </a:spcAft>
+              <a:defRPr sz="2300" b="0">
                 <a:solidFill>
                   <a:srgbClr val="24384A"/>
                 </a:solidFill>
@@ -17690,320 +17764,7 @@
               <a:rPr>
                 <a:ea typeface="Microsoft JhengHei"/>
               </a:rPr>
-              <a:t>and source positions.</a:t>
-            </a:r>
-          </a:p>
-        </p:txBody>
-      </p:sp>
-      <p:sp>
-        <p:nvSpPr>
-          <p:cNvPr id="11" name="TextBox 10"/>
-          <p:cNvSpPr txBox="1"/>
-          <p:nvPr/>
-        </p:nvSpPr>
-        <p:spPr>
-          <a:xfrm>
-            <a:off x="9248775" y="2981325"/>
-            <a:ext cx="2266950" cy="495299"/>
-          </a:xfrm>
-          <a:prstGeom prst="rect">
-            <a:avLst/>
-          </a:prstGeom>
-          <a:noFill/>
-        </p:spPr>
-        <p:txBody>
-          <a:bodyPr wrap="square" lIns="0" tIns="0" rIns="0" bIns="0">
-            <a:spAutoFit/>
-          </a:bodyPr>
-          <a:lstStyle/>
-          <a:p>
-            <a:pPr>
-              <a:lnSpc>
-                <a:spcPct val="118000"/>
-              </a:lnSpc>
-              <a:spcBef>
-                <a:spcPts val="0"/>
-              </a:spcBef>
-              <a:spcAft>
-                <a:spcPts val="0"/>
-              </a:spcAft>
-              <a:defRPr sz="2000" b="1">
-                <a:solidFill>
-                  <a:srgbClr val="65439A"/>
-                </a:solidFill>
-                <a:latin typeface="Lato"/>
-              </a:defRPr>
-            </a:pPr>
-            <a:r>
-              <a:rPr>
-                <a:ea typeface="Microsoft JhengHei"/>
-              </a:rPr>
-              <a:t>Agent proposals</a:t>
-            </a:r>
-          </a:p>
-        </p:txBody>
-      </p:sp>
-      <p:sp>
-        <p:nvSpPr>
-          <p:cNvPr id="12" name="TextBox 11"/>
-          <p:cNvSpPr txBox="1"/>
-          <p:nvPr/>
-        </p:nvSpPr>
-        <p:spPr>
-          <a:xfrm>
-            <a:off x="9248775" y="3657600"/>
-            <a:ext cx="2266950" cy="723900"/>
-          </a:xfrm>
-          <a:prstGeom prst="rect">
-            <a:avLst/>
-          </a:prstGeom>
-          <a:noFill/>
-        </p:spPr>
-        <p:txBody>
-          <a:bodyPr wrap="square" lIns="0" tIns="0" rIns="0" bIns="0">
-            <a:spAutoFit/>
-          </a:bodyPr>
-          <a:lstStyle/>
-          <a:p>
-            <a:pPr>
-              <a:lnSpc>
-                <a:spcPct val="118000"/>
-              </a:lnSpc>
-              <a:spcBef>
-                <a:spcPts val="0"/>
-              </a:spcBef>
-              <a:spcAft>
-                <a:spcPts val="0"/>
-              </a:spcAft>
-              <a:defRPr sz="1900" b="0">
-                <a:solidFill>
-                  <a:srgbClr val="24384A"/>
-                </a:solidFill>
-                <a:latin typeface="Lato"/>
-              </a:defRPr>
-            </a:pPr>
-            <a:r>
-              <a:rPr>
-                <a:ea typeface="Microsoft JhengHei"/>
-              </a:rPr>
-              <a:t>Propose explanations</a:t>
-            </a:r>
-          </a:p>
-          <a:p>
-            <a:pPr>
-              <a:lnSpc>
-                <a:spcPct val="118000"/>
-              </a:lnSpc>
-              <a:spcBef>
-                <a:spcPts val="0"/>
-              </a:spcBef>
-              <a:spcAft>
-                <a:spcPts val="0"/>
-              </a:spcAft>
-              <a:defRPr sz="1900" b="0">
-                <a:solidFill>
-                  <a:srgbClr val="24384A"/>
-                </a:solidFill>
-                <a:latin typeface="Lato"/>
-              </a:defRPr>
-            </a:pPr>
-            <a:r>
-              <a:rPr>
-                <a:ea typeface="Microsoft JhengHei"/>
-              </a:rPr>
-              <a:t>and alternatives.</a:t>
-            </a:r>
-          </a:p>
-        </p:txBody>
-      </p:sp>
-      <p:sp>
-        <p:nvSpPr>
-          <p:cNvPr id="13" name="TextBox 12"/>
-          <p:cNvSpPr txBox="1"/>
-          <p:nvPr/>
-        </p:nvSpPr>
-        <p:spPr>
-          <a:xfrm>
-            <a:off x="723900" y="5143500"/>
-            <a:ext cx="2762250" cy="428625"/>
-          </a:xfrm>
-          <a:prstGeom prst="rect">
-            <a:avLst/>
-          </a:prstGeom>
-          <a:noFill/>
-        </p:spPr>
-        <p:txBody>
-          <a:bodyPr wrap="square" lIns="0" tIns="0" rIns="0" bIns="0">
-            <a:spAutoFit/>
-          </a:bodyPr>
-          <a:lstStyle/>
-          <a:p>
-            <a:pPr>
-              <a:lnSpc>
-                <a:spcPct val="118000"/>
-              </a:lnSpc>
-              <a:spcBef>
-                <a:spcPts val="0"/>
-              </a:spcBef>
-              <a:spcAft>
-                <a:spcPts val="0"/>
-              </a:spcAft>
-              <a:defRPr sz="2300" b="1">
-                <a:solidFill>
-                  <a:srgbClr val="146C68"/>
-                </a:solidFill>
-                <a:latin typeface="Lato"/>
-              </a:defRPr>
-            </a:pPr>
-            <a:r>
-              <a:rPr>
-                <a:ea typeface="Microsoft JhengHei"/>
-              </a:rPr>
-              <a:t>Provenance</a:t>
-            </a:r>
-          </a:p>
-        </p:txBody>
-      </p:sp>
-      <p:sp>
-        <p:nvSpPr>
-          <p:cNvPr id="14" name="TextBox 13"/>
-          <p:cNvSpPr txBox="1"/>
-          <p:nvPr/>
-        </p:nvSpPr>
-        <p:spPr>
-          <a:xfrm>
-            <a:off x="3810000" y="5143500"/>
-            <a:ext cx="7524749" cy="457200"/>
-          </a:xfrm>
-          <a:prstGeom prst="rect">
-            <a:avLst/>
-          </a:prstGeom>
-          <a:noFill/>
-        </p:spPr>
-        <p:txBody>
-          <a:bodyPr wrap="square" lIns="0" tIns="0" rIns="0" bIns="0">
-            <a:spAutoFit/>
-          </a:bodyPr>
-          <a:lstStyle/>
-          <a:p>
-            <a:pPr>
-              <a:lnSpc>
-                <a:spcPct val="118000"/>
-              </a:lnSpc>
-              <a:spcBef>
-                <a:spcPts val="0"/>
-              </a:spcBef>
-              <a:spcAft>
-                <a:spcPts val="0"/>
-              </a:spcAft>
-              <a:defRPr sz="2300" b="0">
-                <a:solidFill>
-                  <a:srgbClr val="24384A"/>
-                </a:solidFill>
-                <a:latin typeface="Lato"/>
-              </a:defRPr>
-            </a:pPr>
-            <a:r>
-              <a:rPr>
-                <a:ea typeface="Microsoft JhengHei"/>
-              </a:rPr>
-              <a:t>Keep sources and checks attached to proposals.</a:t>
-            </a:r>
-          </a:p>
-        </p:txBody>
-      </p:sp>
-      <p:sp>
-        <p:nvSpPr>
-          <p:cNvPr id="15" name="TextBox 14"/>
-          <p:cNvSpPr txBox="1"/>
-          <p:nvPr/>
-        </p:nvSpPr>
-        <p:spPr>
-          <a:xfrm>
-            <a:off x="723900" y="5610225"/>
-            <a:ext cx="2952750" cy="381000"/>
-          </a:xfrm>
-          <a:prstGeom prst="rect">
-            <a:avLst/>
-          </a:prstGeom>
-          <a:noFill/>
-        </p:spPr>
-        <p:txBody>
-          <a:bodyPr wrap="square" lIns="0" tIns="0" rIns="0" bIns="0">
-            <a:spAutoFit/>
-          </a:bodyPr>
-          <a:lstStyle/>
-          <a:p>
-            <a:pPr>
-              <a:lnSpc>
-                <a:spcPct val="118000"/>
-              </a:lnSpc>
-              <a:spcBef>
-                <a:spcPts val="0"/>
-              </a:spcBef>
-              <a:spcAft>
-                <a:spcPts val="0"/>
-              </a:spcAft>
-              <a:defRPr sz="2100" b="1">
-                <a:solidFill>
-                  <a:srgbClr val="146C68"/>
-                </a:solidFill>
-                <a:latin typeface="Lato"/>
-              </a:defRPr>
-            </a:pPr>
-            <a:r>
-              <a:rPr>
-                <a:ea typeface="Microsoft JhengHei"/>
-              </a:rPr>
-              <a:t>Researcher decisions</a:t>
-            </a:r>
-          </a:p>
-        </p:txBody>
-      </p:sp>
-      <p:sp>
-        <p:nvSpPr>
-          <p:cNvPr id="16" name="TextBox 15"/>
-          <p:cNvSpPr txBox="1"/>
-          <p:nvPr/>
-        </p:nvSpPr>
-        <p:spPr>
-          <a:xfrm>
-            <a:off x="3810000" y="5610225"/>
-            <a:ext cx="7524749" cy="400050"/>
-          </a:xfrm>
-          <a:prstGeom prst="rect">
-            <a:avLst/>
-          </a:prstGeom>
-          <a:noFill/>
-        </p:spPr>
-        <p:txBody>
-          <a:bodyPr wrap="square" lIns="0" tIns="0" rIns="0" bIns="0">
-            <a:spAutoFit/>
-          </a:bodyPr>
-          <a:lstStyle/>
-          <a:p>
-            <a:pPr>
-              <a:lnSpc>
-                <a:spcPct val="118000"/>
-              </a:lnSpc>
-              <a:spcBef>
-                <a:spcPts val="0"/>
-              </a:spcBef>
-              <a:spcAft>
-                <a:spcPts val="0"/>
-              </a:spcAft>
-              <a:defRPr sz="2200" b="0">
-                <a:solidFill>
-                  <a:srgbClr val="24384A"/>
-                </a:solidFill>
-                <a:latin typeface="Lato"/>
-              </a:defRPr>
-            </a:pPr>
-            <a:r>
-              <a:rPr>
-                <a:ea typeface="Microsoft JhengHei"/>
-              </a:rPr>
-              <a:t>Inspect the evidence; accept or reject proposals.</a:t>
+              <a:t>The researcher decides what to accept.</a:t>
             </a:r>
           </a:p>
         </p:txBody>
@@ -22314,7 +22075,9 @@
   <we:alternateReferences>
     <we:reference id="wa200010001" version="1.0.0.1" store="wa200010001" storeType="OMEX"/>
   </we:alternateReferences>
-  <we:properties/>
+  <we:properties>
+    <we:property name="claude.fileId" value="&quot;ef803f54-82cd-4662-a865-ae21f3d93cba&quot;"/>
+  </we:properties>
   <we:bindings/>
   <we:snapshot xmlns:r="http://schemas.openxmlformats.org/officeDocument/2006/relationships"/>
 </we:webextension>

</xml_diff>

<commit_message>
Order presentation from Inquiry through Graph to Findings
</commit_message>
<xml_diff>
--- a/docs/presentation/cohort-pnc-2026-main.pptx
+++ b/docs/presentation/cohort-pnc-2026-main.pptx
@@ -22,10 +22,10 @@
     <p:sldId id="267" r:id="rId13"/>
     <p:sldId id="268" r:id="rId14"/>
     <p:sldId id="269" r:id="rId15"/>
-    <p:sldId id="270" r:id="rId16"/>
     <p:sldId id="271" r:id="rId17"/>
     <p:sldId id="272" r:id="rId18"/>
     <p:sldId id="273" r:id="rId19"/>
+    <p:sldId id="270" r:id="rId16"/>
     <p:sldId id="274" r:id="rId20"/>
     <p:sldId id="275" r:id="rId21"/>
   </p:sldIdLst>
@@ -2168,7 +2168,7 @@
           </a:p>
           <a:p>
             <a:r>
-              <a:t>APPLICATION: Corpus → Lotus related passages and shared wording (3 min). Vocabulary comparison → T0603, exclude T1694 (3 min). Inquiry → saved action; Findings → one proposal; Graph → its sources and checks (4 min). Then return to the final slide (20). Do not accept a weak scholarly proposal to demonstrate a button.</a:t>
+              <a:t>APPLICATION: Corpus → Lotus related passages and shared wording (3 min). Vocabulary comparison → T0603, exclude T1694 (3 min). Inquiry → saved action; Graph → sources and checks; Findings → one proposal (4 min). Then return to the final slide (20). Do not accept a weak scholarly proposal to demonstrate a button.</a:t>
             </a:r>
           </a:p>
         </p:txBody>
@@ -11499,7 +11499,7 @@
               <a:rPr>
                 <a:ea typeface="Microsoft JhengHei"/>
               </a:rPr>
-              <a:t>15</a:t>
+              <a:t>18</a:t>
             </a:r>
           </a:p>
         </p:txBody>
@@ -12405,7 +12405,7 @@
               <a:rPr>
                 <a:ea typeface="Microsoft JhengHei"/>
               </a:rPr>
-              <a:t>16</a:t>
+              <a:t>15</a:t>
             </a:r>
           </a:p>
         </p:txBody>
@@ -14233,7 +14233,7 @@
               <a:rPr>
                 <a:ea typeface="Microsoft JhengHei"/>
               </a:rPr>
-              <a:t>17</a:t>
+              <a:t>16</a:t>
             </a:r>
           </a:p>
         </p:txBody>
@@ -14832,7 +14832,7 @@
               <a:rPr>
                 <a:ea typeface="Microsoft JhengHei"/>
               </a:rPr>
-              <a:t>18</a:t>
+              <a:t>17</a:t>
             </a:r>
           </a:p>
         </p:txBody>
@@ -15385,7 +15385,7 @@
               <a:rPr>
                 <a:ea typeface="Microsoft JhengHei"/>
               </a:rPr>
-              <a:t>Saved actions, proposal, citations and checks</a:t>
+              <a:t>Inquiry → Graph → Findings</a:t>
             </a:r>
           </a:p>
         </p:txBody>
@@ -16894,7 +16894,7 @@
               <a:rPr lang="en-US" dirty="0">
                 <a:ea typeface="Microsoft JhengHei"/>
               </a:rPr>
-              <a:t>Cohort’s purpose</a:t>
+              <a:t>Cohort’s goal</a:t>
             </a:r>
             <a:endParaRPr dirty="0">
               <a:ea typeface="Microsoft JhengHei"/>
@@ -18326,7 +18326,7 @@
         </p:nvSpPr>
         <p:spPr>
           <a:xfrm>
-            <a:off x="685800" y="4514850"/>
+            <a:off x="685800" y="5343525"/>
             <a:ext cx="2971800" cy="561975"/>
           </a:xfrm>
           <a:prstGeom prst="rect">
@@ -18374,7 +18374,7 @@
         </p:nvSpPr>
         <p:spPr>
           <a:xfrm>
-            <a:off x="4095750" y="4514850"/>
+            <a:off x="4095750" y="5343525"/>
             <a:ext cx="7505700" cy="609600"/>
           </a:xfrm>
           <a:prstGeom prst="rect">
@@ -18406,7 +18406,7 @@
               </a:defRPr>
             </a:pPr>
             <a:r>
-              <a:rPr>
+              <a:rPr dirty="0">
                 <a:ea typeface="Microsoft JhengHei"/>
               </a:rPr>
               <a:t>Read the agents’ proposals, citations and checks.</a:t>
@@ -18422,7 +18422,7 @@
         </p:nvSpPr>
         <p:spPr>
           <a:xfrm>
-            <a:off x="685800" y="5343525"/>
+            <a:off x="685800" y="4514850"/>
             <a:ext cx="2971800" cy="561975"/>
           </a:xfrm>
           <a:prstGeom prst="rect">
@@ -18470,7 +18470,7 @@
         </p:nvSpPr>
         <p:spPr>
           <a:xfrm>
-            <a:off x="4095750" y="5343525"/>
+            <a:off x="4095750" y="4514850"/>
             <a:ext cx="7505700" cy="609600"/>
           </a:xfrm>
           <a:prstGeom prst="rect">

</xml_diff>

<commit_message>
Clarify observed limits and add closing thank-you slide
</commit_message>
<xml_diff>
--- a/docs/presentation/cohort-pnc-2026-main.pptx
+++ b/docs/presentation/cohort-pnc-2026-main.pptx
@@ -28,6 +28,7 @@
     <p:sldId id="270" r:id="rId19"/>
     <p:sldId id="274" r:id="rId20"/>
     <p:sldId id="275" r:id="rId21"/>
+    <p:sldId id="276" r:id="rId27"/>
   </p:sldIdLst>
   <p:sldSz cx="12192000" cy="6858000"/>
   <p:notesSz cx="6858000" cy="9144000"/>
@@ -16880,7 +16881,7 @@
               <a:spcAft>
                 <a:spcPts val="0"/>
               </a:spcAft>
-              <a:defRPr sz="2700" b="1">
+              <a:defRPr sz="2400" b="1">
                 <a:solidFill>
                   <a:srgbClr val="146C68"/>
                 </a:solidFill>
@@ -16888,10 +16889,7 @@
               </a:defRPr>
             </a:pPr>
             <a:r>
-              <a:rPr>
-                <a:ea typeface="Microsoft JhengHei"/>
-              </a:rPr>
-              <a:t>Useful outputs</a:t>
+              <a:t>What the tools showed</a:t>
             </a:r>
           </a:p>
         </p:txBody>
@@ -16928,7 +16926,7 @@
               <a:spcAft>
                 <a:spcPts val="0"/>
               </a:spcAft>
-              <a:defRPr sz="2700" b="1">
+              <a:defRPr sz="2400" b="1">
                 <a:solidFill>
                   <a:srgbClr val="80511B"/>
                 </a:solidFill>
@@ -16936,10 +16934,7 @@
               </a:defRPr>
             </a:pPr>
             <a:r>
-              <a:rPr>
-                <a:ea typeface="Microsoft JhengHei"/>
-              </a:rPr>
-              <a:t>Observed limits</a:t>
+              <a:t>What we still need to check</a:t>
             </a:r>
           </a:p>
         </p:txBody>
@@ -16976,7 +16971,7 @@
               <a:spcAft>
                 <a:spcPts val="0"/>
               </a:spcAft>
-              <a:defRPr sz="2300" b="0">
+              <a:defRPr sz="2000" b="0">
                 <a:solidFill>
                   <a:srgbClr val="24384A"/>
                 </a:solidFill>
@@ -16984,35 +16979,7 @@
               </a:defRPr>
             </a:pPr>
             <a:r>
-              <a:rPr>
-                <a:ea typeface="Microsoft JhengHei"/>
-              </a:rPr>
-              <a:t>Lotus: a related passage with</a:t>
-            </a:r>
-          </a:p>
-          <a:p>
-            <a:pPr>
-              <a:lnSpc>
-                <a:spcPct val="118000"/>
-              </a:lnSpc>
-              <a:spcBef>
-                <a:spcPts val="0"/>
-              </a:spcBef>
-              <a:spcAft>
-                <a:spcPts val="0"/>
-              </a:spcAft>
-              <a:defRPr sz="2300" b="0">
-                <a:solidFill>
-                  <a:srgbClr val="24384A"/>
-                </a:solidFill>
-                <a:latin typeface="Lato"/>
-              </a:defRPr>
-            </a:pPr>
-            <a:r>
-              <a:rPr>
-                <a:ea typeface="Microsoft JhengHei"/>
-              </a:rPr>
-              <a:t>little exact shared wording.</a:t>
+              <a:t>The Lotus search found a passage in another translation despite little exact shared wording.</a:t>
             </a:r>
           </a:p>
         </p:txBody>
@@ -17049,7 +17016,7 @@
               <a:spcAft>
                 <a:spcPts val="0"/>
               </a:spcAft>
-              <a:defRPr sz="2300" b="0">
+              <a:defRPr sz="2000" b="0">
                 <a:solidFill>
                   <a:srgbClr val="24384A"/>
                 </a:solidFill>
@@ -17057,35 +17024,7 @@
               </a:defRPr>
             </a:pPr>
             <a:r>
-              <a:rPr>
-                <a:ea typeface="Microsoft JhengHei"/>
-              </a:rPr>
-              <a:t>Kumārajīva’s Lotus wrongly ranks</a:t>
-            </a:r>
-          </a:p>
-          <a:p>
-            <a:pPr>
-              <a:lnSpc>
-                <a:spcPct val="118000"/>
-              </a:lnSpc>
-              <a:spcBef>
-                <a:spcPts val="0"/>
-              </a:spcBef>
-              <a:spcAft>
-                <a:spcPts val="0"/>
-              </a:spcAft>
-              <a:defRPr sz="2300" b="0">
-                <a:solidFill>
-                  <a:srgbClr val="24384A"/>
-                </a:solidFill>
-                <a:latin typeface="Lato"/>
-              </a:defRPr>
-            </a:pPr>
-            <a:r>
-              <a:rPr>
-                <a:ea typeface="Microsoft JhengHei"/>
-              </a:rPr>
-              <a:t>Dharmakṣema first in vocabulary.</a:t>
+              <a:t>T0262 Lotus: known translator Kumārajīva 鳩摩羅什; vocabulary ranks Dharmakṣema 曇無讖 first.</a:t>
             </a:r>
           </a:p>
         </p:txBody>
@@ -17122,7 +17061,7 @@
               <a:spcAft>
                 <a:spcPts val="0"/>
               </a:spcAft>
-              <a:defRPr sz="2300" b="0">
+              <a:defRPr sz="2000" b="0">
                 <a:solidFill>
                   <a:srgbClr val="24384A"/>
                 </a:solidFill>
@@ -17130,35 +17069,7 @@
               </a:defRPr>
             </a:pPr>
             <a:r>
-              <a:rPr>
-                <a:ea typeface="Microsoft JhengHei"/>
-              </a:rPr>
-              <a:t>T0603: exclusion exposes the</a:t>
-            </a:r>
-          </a:p>
-          <a:p>
-            <a:pPr>
-              <a:lnSpc>
-                <a:spcPct val="118000"/>
-              </a:lnSpc>
-              <a:spcBef>
-                <a:spcPts val="0"/>
-              </a:spcBef>
-              <a:spcAft>
-                <a:spcPts val="0"/>
-              </a:spcAft>
-              <a:defRPr sz="2300" b="0">
-                <a:solidFill>
-                  <a:srgbClr val="24384A"/>
-                </a:solidFill>
-                <a:latin typeface="Lato"/>
-              </a:defRPr>
-            </a:pPr>
-            <a:r>
-              <a:rPr>
-                <a:ea typeface="Microsoft JhengHei"/>
-              </a:rPr>
-              <a:t>commentary’s effect on the ranking.</a:t>
+              <a:t>Removing T0603’s commentary changes which vocabulary group ranks first.</a:t>
             </a:r>
           </a:p>
         </p:txBody>
@@ -17195,7 +17106,7 @@
               <a:spcAft>
                 <a:spcPts val="0"/>
               </a:spcAft>
-              <a:defRPr sz="2300" b="0">
+              <a:defRPr sz="2000" b="0">
                 <a:solidFill>
                   <a:srgbClr val="24384A"/>
                 </a:solidFill>
@@ -17203,35 +17114,7 @@
               </a:defRPr>
             </a:pPr>
             <a:r>
-              <a:rPr>
-                <a:ea typeface="Microsoft JhengHei"/>
-              </a:rPr>
-              <a:t>One known-answer example</a:t>
-            </a:r>
-          </a:p>
-          <a:p>
-            <a:pPr>
-              <a:lnSpc>
-                <a:spcPct val="118000"/>
-              </a:lnSpc>
-              <a:spcBef>
-                <a:spcPts val="0"/>
-              </a:spcBef>
-              <a:spcAft>
-                <a:spcPts val="0"/>
-              </a:spcAft>
-              <a:defRPr sz="2300" b="0">
-                <a:solidFill>
-                  <a:srgbClr val="24384A"/>
-                </a:solidFill>
-                <a:latin typeface="Lato"/>
-              </a:defRPr>
-            </a:pPr>
-            <a:r>
-              <a:rPr>
-                <a:ea typeface="Microsoft JhengHei"/>
-              </a:rPr>
-              <a:t>cannot validate attribution.</a:t>
+              <a:t>Getting one text right does not show that the method reliably identifies unknown translators.</a:t>
             </a:r>
           </a:p>
         </p:txBody>
@@ -17268,7 +17151,7 @@
               <a:spcAft>
                 <a:spcPts val="0"/>
               </a:spcAft>
-              <a:defRPr sz="2300" b="0">
+              <a:defRPr sz="2000" b="0">
                 <a:solidFill>
                   <a:srgbClr val="24384A"/>
                 </a:solidFill>
@@ -17276,35 +17159,7 @@
               </a:defRPr>
             </a:pPr>
             <a:r>
-              <a:rPr>
-                <a:ea typeface="Microsoft JhengHei"/>
-              </a:rPr>
-              <a:t>Proposals, sources and checks</a:t>
-            </a:r>
-          </a:p>
-          <a:p>
-            <a:pPr>
-              <a:lnSpc>
-                <a:spcPct val="118000"/>
-              </a:lnSpc>
-              <a:spcBef>
-                <a:spcPts val="0"/>
-              </a:spcBef>
-              <a:spcAft>
-                <a:spcPts val="0"/>
-              </a:spcAft>
-              <a:defRPr sz="2300" b="0">
-                <a:solidFill>
-                  <a:srgbClr val="24384A"/>
-                </a:solidFill>
-                <a:latin typeface="Lato"/>
-              </a:defRPr>
-            </a:pPr>
-            <a:r>
-              <a:rPr>
-                <a:ea typeface="Microsoft JhengHei"/>
-              </a:rPr>
-              <a:t>can be inspected together.</a:t>
+              <a:t>The graph brings proposals, cited passages and recorded checks together.</a:t>
             </a:r>
           </a:p>
         </p:txBody>
@@ -17341,7 +17196,7 @@
               <a:spcAft>
                 <a:spcPts val="0"/>
               </a:spcAft>
-              <a:defRPr sz="2300" b="0">
+              <a:defRPr sz="2000" b="0">
                 <a:solidFill>
                   <a:srgbClr val="24384A"/>
                 </a:solidFill>
@@ -17349,35 +17204,7 @@
               </a:defRPr>
             </a:pPr>
             <a:r>
-              <a:rPr>
-                <a:ea typeface="Microsoft JhengHei"/>
-              </a:rPr>
-              <a:t>Weak tests and reviewer errors</a:t>
-            </a:r>
-          </a:p>
-          <a:p>
-            <a:pPr>
-              <a:lnSpc>
-                <a:spcPct val="118000"/>
-              </a:lnSpc>
-              <a:spcBef>
-                <a:spcPts val="0"/>
-              </a:spcBef>
-              <a:spcAft>
-                <a:spcPts val="0"/>
-              </a:spcAft>
-              <a:defRPr sz="2300" b="0">
-                <a:solidFill>
-                  <a:srgbClr val="24384A"/>
-                </a:solidFill>
-                <a:latin typeface="Lato"/>
-              </a:defRPr>
-            </a:pPr>
-            <a:r>
-              <a:rPr>
-                <a:ea typeface="Microsoft JhengHei"/>
-              </a:rPr>
-              <a:t>still require researcher scrutiny.</a:t>
+              <a:t>Researchers still need to assess the interpretation and whether its tests are useful.</a:t>
             </a:r>
           </a:p>
         </p:txBody>
@@ -17524,6 +17351,218 @@
           <a:p>
             <a:pPr algn="l"/>
             <a:endParaRPr lang="zh-TW" altLang="en-US"/>
+          </a:p>
+        </p:txBody>
+      </p:sp>
+    </p:spTree>
+  </p:cSld>
+  <p:clrMapOvr>
+    <a:masterClrMapping/>
+  </p:clrMapOvr>
+</p:sld>
+</file>
+
+<file path=ppt/slides/slide21.xml><?xml version="1.0" encoding="utf-8"?>
+<p:sld xmlns:a="http://schemas.openxmlformats.org/drawingml/2006/main" xmlns:r="http://schemas.openxmlformats.org/officeDocument/2006/relationships" xmlns:p="http://schemas.openxmlformats.org/presentationml/2006/main">
+  <p:cSld>
+    <p:spTree>
+      <p:nvGrpSpPr>
+        <p:cNvPr id="1" name=""/>
+        <p:cNvGrpSpPr/>
+        <p:nvPr/>
+      </p:nvGrpSpPr>
+      <p:grpSpPr>
+        <a:xfrm>
+          <a:off x="0" y="0"/>
+          <a:ext cx="0" cy="0"/>
+          <a:chOff x="0" y="0"/>
+          <a:chExt cx="0" cy="0"/>
+        </a:xfrm>
+      </p:grpSpPr>
+      <p:sp>
+        <p:nvSpPr>
+          <p:cNvPr id="3" name="TextBox 2"/>
+          <p:cNvSpPr txBox="1"/>
+          <p:nvPr/>
+        </p:nvSpPr>
+        <p:spPr>
+          <a:xfrm>
+            <a:off x="952500" y="2381250"/>
+            <a:ext cx="10287000" cy="1143000"/>
+          </a:xfrm>
+          <a:prstGeom prst="rect">
+            <a:avLst/>
+          </a:prstGeom>
+          <a:noFill/>
+        </p:spPr>
+        <p:txBody>
+          <a:bodyPr wrap="square" lIns="0" tIns="0" rIns="0" bIns="0">
+            <a:spAutoFit/>
+          </a:bodyPr>
+          <a:lstStyle/>
+          <a:p>
+            <a:pPr algn="ctr">
+              <a:lnSpc>
+                <a:spcPct val="118000"/>
+              </a:lnSpc>
+              <a:spcBef>
+                <a:spcPts val="0"/>
+              </a:spcBef>
+              <a:spcAft>
+                <a:spcPts val="0"/>
+              </a:spcAft>
+              <a:defRPr sz="5200" b="1">
+                <a:solidFill>
+                  <a:srgbClr val="24384A"/>
+                </a:solidFill>
+                <a:latin typeface="Lato"/>
+              </a:defRPr>
+            </a:pPr>
+            <a:r>
+              <a:rPr>
+                <a:ea typeface="Microsoft JhengHei"/>
+              </a:rPr>
+              <a:t>Thank you</a:t>
+            </a:r>
+          </a:p>
+        </p:txBody>
+      </p:sp>
+      <p:sp>
+        <p:nvSpPr>
+          <p:cNvPr id="4" name="TextBox 3"/>
+          <p:cNvSpPr txBox="1"/>
+          <p:nvPr/>
+        </p:nvSpPr>
+        <p:spPr>
+          <a:xfrm>
+            <a:off x="952500" y="3619500"/>
+            <a:ext cx="10287000" cy="571500"/>
+          </a:xfrm>
+          <a:prstGeom prst="rect">
+            <a:avLst/>
+          </a:prstGeom>
+          <a:noFill/>
+        </p:spPr>
+        <p:txBody>
+          <a:bodyPr wrap="square" lIns="0" tIns="0" rIns="0" bIns="0">
+            <a:spAutoFit/>
+          </a:bodyPr>
+          <a:lstStyle/>
+          <a:p>
+            <a:pPr algn="ctr">
+              <a:lnSpc>
+                <a:spcPct val="118000"/>
+              </a:lnSpc>
+              <a:spcBef>
+                <a:spcPts val="0"/>
+              </a:spcBef>
+              <a:spcAft>
+                <a:spcPts val="0"/>
+              </a:spcAft>
+              <a:defRPr sz="2200" b="1">
+                <a:solidFill>
+                  <a:srgbClr val="146C68"/>
+                </a:solidFill>
+                <a:latin typeface="Lato"/>
+              </a:defRPr>
+            </a:pPr>
+            <a:r>
+              <a:t>Cohort · PNC 2026</a:t>
+            </a:r>
+          </a:p>
+        </p:txBody>
+      </p:sp>
+      <p:sp>
+        <p:nvSpPr>
+          <p:cNvPr id="12" name="Rectangle 11"/>
+          <p:cNvSpPr/>
+          <p:nvPr/>
+        </p:nvSpPr>
+        <p:spPr>
+          <a:xfrm>
+            <a:off x="11334750" y="6429375"/>
+            <a:ext cx="647700" cy="333375"/>
+          </a:xfrm>
+          <a:prstGeom prst="rect">
+            <a:avLst/>
+          </a:prstGeom>
+          <a:solidFill>
+            <a:srgbClr val="24384A"/>
+          </a:solidFill>
+          <a:ln w="12700">
+            <a:solidFill>
+              <a:srgbClr val="24384A"/>
+            </a:solidFill>
+          </a:ln>
+        </p:spPr>
+        <p:style>
+          <a:lnRef idx="1">
+            <a:schemeClr val="accent1"/>
+          </a:lnRef>
+          <a:fillRef idx="3">
+            <a:schemeClr val="accent1"/>
+          </a:fillRef>
+          <a:effectRef idx="2">
+            <a:schemeClr val="accent1"/>
+          </a:effectRef>
+          <a:fontRef idx="minor">
+            <a:schemeClr val="lt1"/>
+          </a:fontRef>
+        </p:style>
+        <p:txBody>
+          <a:bodyPr rtlCol="0" anchor="ctr"/>
+          <a:lstStyle/>
+          <a:p>
+            <a:pPr algn="ctr"/>
+            <a:endParaRPr/>
+          </a:p>
+        </p:txBody>
+      </p:sp>
+      <p:sp>
+        <p:nvSpPr>
+          <p:cNvPr id="13" name="TextBox 12"/>
+          <p:cNvSpPr txBox="1"/>
+          <p:nvPr/>
+        </p:nvSpPr>
+        <p:spPr>
+          <a:xfrm>
+            <a:off x="11477625" y="6477000"/>
+            <a:ext cx="438150" cy="276225"/>
+          </a:xfrm>
+          <a:prstGeom prst="rect">
+            <a:avLst/>
+          </a:prstGeom>
+          <a:noFill/>
+        </p:spPr>
+        <p:txBody>
+          <a:bodyPr wrap="square" lIns="0" tIns="0" rIns="0" bIns="0">
+            <a:spAutoFit/>
+          </a:bodyPr>
+          <a:lstStyle/>
+          <a:p>
+            <a:pPr>
+              <a:lnSpc>
+                <a:spcPct val="118000"/>
+              </a:lnSpc>
+              <a:spcBef>
+                <a:spcPts val="0"/>
+              </a:spcBef>
+              <a:spcAft>
+                <a:spcPts val="0"/>
+              </a:spcAft>
+              <a:defRPr sz="1600" b="1">
+                <a:solidFill>
+                  <a:srgbClr val="FFFFFF"/>
+                </a:solidFill>
+                <a:latin typeface="Lato"/>
+              </a:defRPr>
+            </a:pPr>
+            <a:r>
+              <a:rPr>
+                <a:ea typeface="Microsoft JhengHei"/>
+              </a:rPr>
+              <a:t>21</a:t>
+            </a:r>
           </a:p>
         </p:txBody>
       </p:sp>

</xml_diff>

<commit_message>
Explain evidence graph records and textual relationships in slides
</commit_message>
<xml_diff>
--- a/docs/presentation/cohort-pnc-2026-main.pptx
+++ b/docs/presentation/cohort-pnc-2026-main.pptx
@@ -5,7 +5,7 @@
     <p:sldMasterId id="2147483648" r:id="rId1"/>
   </p:sldMasterIdLst>
   <p:notesMasterIdLst>
-    <p:notesMasterId r:id="rId22"/>
+    <p:notesMasterId r:id="rId23"/>
   </p:notesMasterIdLst>
   <p:sldIdLst>
     <p:sldId id="256" r:id="rId2"/>
@@ -28,7 +28,7 @@
     <p:sldId id="270" r:id="rId19"/>
     <p:sldId id="274" r:id="rId20"/>
     <p:sldId id="275" r:id="rId21"/>
-    <p:sldId id="276" r:id="rId27"/>
+    <p:sldId id="276" r:id="rId22"/>
   </p:sldIdLst>
   <p:sldSz cx="12192000" cy="6858000"/>
   <p:notesSz cx="6858000" cy="9144000"/>
@@ -923,35 +923,48 @@
           <a:lstStyle/>
           <a:p>
             <a:r>
+              <a:rPr dirty="0"/>
               <a:t>SAY: Compare a text’s wording with texts labelled by translator.</a:t>
             </a:r>
           </a:p>
           <a:p>
-            <a:endParaRPr/>
-          </a:p>
-          <a:p>
-            <a:r>
-              <a:t>SAY: Read the group names beside A and B. Highlighting is the contribution to their score difference. The strings can occur in both groups. Strong colour is not certainty.</a:t>
-            </a:r>
-          </a:p>
-          <a:p>
-            <a:endParaRPr/>
-          </a:p>
-          <a:p>
-            <a:r>
+            <a:endParaRPr dirty="0"/>
+          </a:p>
+          <a:p>
+            <a:r>
+              <a:rPr dirty="0"/>
+              <a:t>SAY: Read the group names beside A and B. Highlighting is the contribution to their score difference. The strings can occur in both groups. Strong </a:t>
+            </a:r>
+            <a:r>
+              <a:rPr dirty="0" err="1"/>
+              <a:t>colour</a:t>
+            </a:r>
+            <a:r>
+              <a:rPr dirty="0"/>
+              <a:t> is not certainty.</a:t>
+            </a:r>
+          </a:p>
+          <a:p>
+            <a:endParaRPr dirty="0"/>
+          </a:p>
+          <a:p>
+            <a:r>
+              <a:rPr dirty="0"/>
               <a:t>BACKGROUND</a:t>
             </a:r>
           </a:p>
           <a:p>
             <a:r>
+              <a:rPr dirty="0"/>
               <a:t>This compares a text against pooled groups using string counts, not embeddings. Use the live view for exclusions. Source passages are hidden in the screenshot. </a:t>
             </a:r>
           </a:p>
           <a:p>
-            <a:endParaRPr/>
-          </a:p>
-          <a:p>
-            <a:r>
+            <a:endParaRPr dirty="0"/>
+          </a:p>
+          <a:p>
+            <a:r>
+              <a:rPr dirty="0"/>
               <a:t>VISUAL: The screenshot orients the audience; the diagram explains the operation. Read the diagram first. Its arrows show UI workflow, not evidence-graph edge types. In Corpus the two top boxes are alternative search modes; in Vocabulary comparison and Inquiry they are inputs used together.</a:t>
             </a:r>
           </a:p>
@@ -7249,7 +7262,7 @@
         <p:spPr>
           <a:xfrm>
             <a:off x="714375" y="3121025"/>
-            <a:ext cx="2857500" cy="1809750"/>
+            <a:ext cx="2857500" cy="621260"/>
           </a:xfrm>
           <a:prstGeom prst="rect">
             <a:avLst/>
@@ -7280,30 +7293,10 @@
               </a:defRPr>
             </a:pPr>
             <a:r>
-              <a:t>Radich: strings selected for a Dharmarakṣa dictionary.</a:t>
-            </a:r>
-          </a:p>
-          <a:p>
-            <a:pPr>
-              <a:lnSpc>
-                <a:spcPct val="118000"/>
-              </a:lnSpc>
-              <a:spcBef>
-                <a:spcPts val="0"/>
-              </a:spcBef>
-              <a:spcAft>
-                <a:spcPts val="0"/>
-              </a:spcAft>
-              <a:defRPr sz="1800" b="0">
-                <a:solidFill>
-                  <a:srgbClr val="24384A"/>
-                </a:solidFill>
-                <a:latin typeface="Lato"/>
-              </a:defRPr>
-            </a:pPr>
-            <a:r>
-              <a:t>Frequent: common strings in translator-uncertain texts; no group labels used.</a:t>
-            </a:r>
+              <a:rPr lang="en-US" dirty="0"/>
+              <a:t>A list of discriminative strings used to score texts.</a:t>
+            </a:r>
+            <a:endParaRPr dirty="0"/>
           </a:p>
         </p:txBody>
       </p:sp>
@@ -7510,6 +7503,7 @@
               </a:defRPr>
             </a:pPr>
             <a:r>
+              <a:rPr dirty="0"/>
               <a:t>Count the same strings in reference texts with catalogue group labels.</a:t>
             </a:r>
           </a:p>
@@ -7532,6 +7526,7 @@
               </a:defRPr>
             </a:pPr>
             <a:r>
+              <a:rPr dirty="0"/>
               <a:t>Use relative frequencies; exclude the target’s own work.</a:t>
             </a:r>
           </a:p>
@@ -9436,7 +9431,7 @@
               <a:rPr lang="en-US" dirty="0">
                 <a:ea typeface="Microsoft JhengHei"/>
               </a:rPr>
-              <a:t> with large spans of overlap, artificially boosting similarity</a:t>
+              <a:t> with large spans of overlap, artificially boosting similarity.</a:t>
             </a:r>
             <a:endParaRPr dirty="0">
               <a:ea typeface="Microsoft JhengHei"/>
@@ -10685,7 +10680,7 @@
         <p:spPr>
           <a:xfrm>
             <a:off x="495299" y="742950"/>
-            <a:ext cx="11144250" cy="952500"/>
+            <a:ext cx="11144250" cy="523220"/>
           </a:xfrm>
           <a:prstGeom prst="rect">
             <a:avLst/>
@@ -10716,11 +10711,14 @@
               </a:defRPr>
             </a:pPr>
             <a:r>
-              <a:rPr>
-                <a:ea typeface="Microsoft JhengHei"/>
-              </a:rPr>
-              <a:t>From passages to research proposals</a:t>
-            </a:r>
+              <a:rPr lang="en-US" dirty="0">
+                <a:ea typeface="Microsoft JhengHei"/>
+              </a:rPr>
+              <a:t>New research directions</a:t>
+            </a:r>
+            <a:endParaRPr dirty="0">
+              <a:ea typeface="Microsoft JhengHei"/>
+            </a:endParaRPr>
           </a:p>
         </p:txBody>
       </p:sp>
@@ -11401,8 +11399,8 @@
         </p:nvSpPr>
         <p:spPr>
           <a:xfrm>
-            <a:off x="2762250" y="5105400"/>
-            <a:ext cx="8858250" cy="762000"/>
+            <a:off x="1759058" y="5141172"/>
+            <a:ext cx="9861442" cy="376129"/>
           </a:xfrm>
           <a:prstGeom prst="rect">
             <a:avLst/>
@@ -11433,58 +11431,10 @@
               </a:defRPr>
             </a:pPr>
             <a:r>
-              <a:rPr>
+              <a:rPr dirty="0">
                 <a:ea typeface="Microsoft JhengHei"/>
               </a:rPr>
               <a:t>Keeps proposals linked to passages, checks and researcher decisions.</a:t>
-            </a:r>
-          </a:p>
-        </p:txBody>
-      </p:sp>
-      <p:sp>
-        <p:nvSpPr>
-          <p:cNvPr id="18" name="TextBox 17"/>
-          <p:cNvSpPr txBox="1"/>
-          <p:nvPr/>
-        </p:nvSpPr>
-        <p:spPr>
-          <a:xfrm>
-            <a:off x="523874" y="5962650"/>
-            <a:ext cx="11049000" cy="390525"/>
-          </a:xfrm>
-          <a:prstGeom prst="rect">
-            <a:avLst/>
-          </a:prstGeom>
-          <a:noFill/>
-        </p:spPr>
-        <p:txBody>
-          <a:bodyPr wrap="square" lIns="0" tIns="0" rIns="0" bIns="0">
-            <a:spAutoFit/>
-          </a:bodyPr>
-          <a:lstStyle/>
-          <a:p>
-            <a:pPr>
-              <a:lnSpc>
-                <a:spcPct val="118000"/>
-              </a:lnSpc>
-              <a:spcBef>
-                <a:spcPts val="0"/>
-              </a:spcBef>
-              <a:spcAft>
-                <a:spcPts val="0"/>
-              </a:spcAft>
-              <a:defRPr sz="2200" b="0">
-                <a:solidFill>
-                  <a:srgbClr val="526778"/>
-                </a:solidFill>
-                <a:latin typeface="Lato"/>
-              </a:defRPr>
-            </a:pPr>
-            <a:r>
-              <a:rPr>
-                <a:ea typeface="Microsoft JhengHei"/>
-              </a:rPr>
-              <a:t>A citation that resolves can still support a weak interpretation.</a:t>
             </a:r>
           </a:p>
         </p:txBody>
@@ -11750,7 +11700,7 @@
               <a:rPr>
                 <a:ea typeface="Microsoft JhengHei"/>
               </a:rPr>
-              <a:t>Follow links between sources, proposals and decisions.</a:t>
+              <a:t>Graph: connect proposals to sources and checks.</a:t>
             </a:r>
           </a:p>
         </p:txBody>
@@ -12363,7 +12313,7 @@
               </a:defRPr>
             </a:pPr>
             <a:r>
-              <a:rPr>
+              <a:rPr dirty="0">
                 <a:ea typeface="Microsoft JhengHei"/>
               </a:rPr>
               <a:t>Show exploration adds recorded tool activity.</a:t>
@@ -12600,7 +12550,7 @@
         <p:spPr>
           <a:xfrm>
             <a:off x="495299" y="742950"/>
-            <a:ext cx="11144250" cy="1047749"/>
+            <a:ext cx="11144250" cy="523220"/>
           </a:xfrm>
           <a:prstGeom prst="rect">
             <a:avLst/>
@@ -12631,11 +12581,14 @@
               </a:defRPr>
             </a:pPr>
             <a:r>
-              <a:rPr>
-                <a:ea typeface="Microsoft JhengHei"/>
-              </a:rPr>
-              <a:t>Why a query points to a proposal</a:t>
-            </a:r>
+              <a:rPr lang="en-US" dirty="0">
+                <a:ea typeface="Microsoft JhengHei"/>
+              </a:rPr>
+              <a:t>Relationships between nodes</a:t>
+            </a:r>
+            <a:endParaRPr dirty="0">
+              <a:ea typeface="Microsoft JhengHei"/>
+            </a:endParaRPr>
           </a:p>
         </p:txBody>
       </p:sp>
@@ -12694,7 +12647,7 @@
         <p:spPr>
           <a:xfrm>
             <a:off x="714375" y="2257425"/>
-            <a:ext cx="2000250" cy="714375"/>
+            <a:ext cx="2000250" cy="359714"/>
           </a:xfrm>
           <a:prstGeom prst="rect">
             <a:avLst/>
@@ -12707,17 +12660,17 @@
           </a:bodyPr>
           <a:lstStyle/>
           <a:p>
-            <a:pPr>
-              <a:lnSpc>
-                <a:spcPct val="118000"/>
-              </a:lnSpc>
-              <a:spcBef>
-                <a:spcPts val="0"/>
-              </a:spcBef>
-              <a:spcAft>
-                <a:spcPts val="0"/>
-              </a:spcAft>
-              <a:defRPr sz="2200" b="1">
+            <a:pPr algn="ctr">
+              <a:lnSpc>
+                <a:spcPct val="118000"/>
+              </a:lnSpc>
+              <a:spcBef>
+                <a:spcPts val="0"/>
+              </a:spcBef>
+              <a:spcAft>
+                <a:spcPts val="0"/>
+              </a:spcAft>
+              <a:defRPr sz="1900" b="1">
                 <a:solidFill>
                   <a:srgbClr val="24384A"/>
                 </a:solidFill>
@@ -12725,10 +12678,10 @@
               </a:defRPr>
             </a:pPr>
             <a:r>
-              <a:rPr>
-                <a:ea typeface="Microsoft JhengHei"/>
-              </a:rPr>
-              <a:t>Witness</a:t>
+              <a:rPr dirty="0">
+                <a:ea typeface="Microsoft JhengHei"/>
+              </a:rPr>
+              <a:t>Source record</a:t>
             </a:r>
           </a:p>
         </p:txBody>
@@ -12788,7 +12741,7 @@
         <p:spPr>
           <a:xfrm>
             <a:off x="4048124" y="2257425"/>
-            <a:ext cx="2000250" cy="714375"/>
+            <a:ext cx="2000250" cy="359714"/>
           </a:xfrm>
           <a:prstGeom prst="rect">
             <a:avLst/>
@@ -12801,7 +12754,7 @@
           </a:bodyPr>
           <a:lstStyle/>
           <a:p>
-            <a:pPr>
+            <a:pPr algn="ctr">
               <a:lnSpc>
                 <a:spcPct val="118000"/>
               </a:lnSpc>
@@ -12819,7 +12772,7 @@
               </a:defRPr>
             </a:pPr>
             <a:r>
-              <a:rPr>
+              <a:rPr dirty="0">
                 <a:ea typeface="Microsoft JhengHei"/>
               </a:rPr>
               <a:t>Passage</a:t>
@@ -12869,7 +12822,7 @@
           <a:lstStyle/>
           <a:p>
             <a:pPr algn="ctr"/>
-            <a:endParaRPr/>
+            <a:endParaRPr sz="1400"/>
           </a:p>
         </p:txBody>
       </p:sp>
@@ -12881,8 +12834,8 @@
         </p:nvSpPr>
         <p:spPr>
           <a:xfrm>
-            <a:off x="8486775" y="2257425"/>
-            <a:ext cx="1352550" cy="666750"/>
+            <a:off x="8045907" y="2297683"/>
+            <a:ext cx="2373986" cy="277961"/>
           </a:xfrm>
           <a:prstGeom prst="rect">
             <a:avLst/>
@@ -12895,7 +12848,7 @@
           </a:bodyPr>
           <a:lstStyle/>
           <a:p>
-            <a:pPr>
+            <a:pPr algn="ctr">
               <a:lnSpc>
                 <a:spcPct val="118000"/>
               </a:lnSpc>
@@ -12913,32 +12866,19 @@
               </a:defRPr>
             </a:pPr>
             <a:r>
-              <a:rPr>
+              <a:rPr dirty="0">
                 <a:ea typeface="Microsoft JhengHei"/>
               </a:rPr>
               <a:t>Claim /</a:t>
             </a:r>
-          </a:p>
-          <a:p>
-            <a:pPr>
-              <a:lnSpc>
-                <a:spcPct val="118000"/>
-              </a:lnSpc>
-              <a:spcBef>
-                <a:spcPts val="0"/>
-              </a:spcBef>
-              <a:spcAft>
-                <a:spcPts val="0"/>
-              </a:spcAft>
-              <a:defRPr sz="1700" b="1">
-                <a:solidFill>
-                  <a:srgbClr val="24384A"/>
-                </a:solidFill>
-                <a:latin typeface="Lato"/>
-              </a:defRPr>
-            </a:pPr>
-            <a:r>
-              <a:rPr>
+            <a:r>
+              <a:rPr lang="en-US" dirty="0">
+                <a:ea typeface="Microsoft JhengHei"/>
+              </a:rPr>
+              <a:t> </a:t>
+            </a:r>
+            <a:r>
+              <a:rPr dirty="0">
                 <a:ea typeface="Microsoft JhengHei"/>
               </a:rPr>
               <a:t>conjecture</a:t>
@@ -13001,7 +12941,7 @@
         <p:spPr>
           <a:xfrm>
             <a:off x="4048124" y="4381500"/>
-            <a:ext cx="2000250" cy="714375"/>
+            <a:ext cx="2000250" cy="359714"/>
           </a:xfrm>
           <a:prstGeom prst="rect">
             <a:avLst/>
@@ -13014,7 +12954,7 @@
           </a:bodyPr>
           <a:lstStyle/>
           <a:p>
-            <a:pPr>
+            <a:pPr algn="ctr">
               <a:lnSpc>
                 <a:spcPct val="118000"/>
               </a:lnSpc>
@@ -13032,7 +12972,7 @@
               </a:defRPr>
             </a:pPr>
             <a:r>
-              <a:rPr>
+              <a:rPr dirty="0">
                 <a:ea typeface="Microsoft JhengHei"/>
               </a:rPr>
               <a:t>Query</a:t>
@@ -13048,8 +12988,8 @@
         </p:nvSpPr>
         <p:spPr>
           <a:xfrm>
-            <a:off x="8858250" y="4333875"/>
-            <a:ext cx="2000250" cy="1285875"/>
+            <a:off x="7876127" y="4572000"/>
+            <a:ext cx="2535744" cy="2085975"/>
           </a:xfrm>
           <a:prstGeom prst="star5">
             <a:avLst/>
@@ -13086,49 +13026,6 @@
           </a:p>
         </p:txBody>
       </p:sp>
-      <p:sp>
-        <p:nvSpPr>
-          <p:cNvPr id="13" name="TextBox 12"/>
-          <p:cNvSpPr txBox="1"/>
-          <p:nvPr/>
-        </p:nvSpPr>
-        <p:spPr>
-          <a:xfrm>
-            <a:off x="9048750" y="4591050"/>
-            <a:ext cx="1619250" cy="1047749"/>
-          </a:xfrm>
-          <a:prstGeom prst="rect">
-            <a:avLst/>
-          </a:prstGeom>
-          <a:noFill/>
-        </p:spPr>
-        <p:txBody>
-          <a:bodyPr wrap="square" lIns="0" tIns="0" rIns="0" bIns="0">
-            <a:spAutoFit/>
-          </a:bodyPr>
-          <a:lstStyle/>
-          <a:p>
-            <a:pPr>
-              <a:lnSpc>
-                <a:spcPct val="118000"/>
-              </a:lnSpc>
-              <a:spcBef>
-                <a:spcPts val="0"/>
-              </a:spcBef>
-              <a:spcAft>
-                <a:spcPts val="0"/>
-              </a:spcAft>
-              <a:defRPr sz="2200" b="1">
-                <a:solidFill>
-                  <a:srgbClr val="24384A"/>
-                </a:solidFill>
-                <a:latin typeface="Lato"/>
-              </a:defRPr>
-            </a:pPr>
-            <a:endParaRPr/>
-          </a:p>
-        </p:txBody>
-      </p:sp>
       <p:cxnSp>
         <p:nvCxnSpPr>
           <p:cNvPr id="14" name="Connector 13"/>
@@ -13173,7 +13070,7 @@
         </p:nvSpPr>
         <p:spPr>
           <a:xfrm>
-            <a:off x="2959100" y="2076450"/>
+            <a:off x="3003090" y="2122338"/>
             <a:ext cx="889000" cy="314325"/>
           </a:xfrm>
           <a:prstGeom prst="rect">
@@ -13205,7 +13102,7 @@
               </a:defRPr>
             </a:pPr>
             <a:r>
-              <a:rPr>
+              <a:rPr dirty="0">
                 <a:ea typeface="Microsoft JhengHei"/>
               </a:rPr>
               <a:t>contains</a:t>
@@ -13257,8 +13154,8 @@
         </p:nvSpPr>
         <p:spPr>
           <a:xfrm>
-            <a:off x="6486525" y="2076450"/>
-            <a:ext cx="952500" cy="314325"/>
+            <a:off x="6617158" y="2080323"/>
+            <a:ext cx="952500" cy="228909"/>
           </a:xfrm>
           <a:prstGeom prst="rect">
             <a:avLst/>
@@ -13271,7 +13168,7 @@
           </a:bodyPr>
           <a:lstStyle/>
           <a:p>
-            <a:pPr>
+            <a:pPr algn="ctr">
               <a:lnSpc>
                 <a:spcPct val="118000"/>
               </a:lnSpc>
@@ -13289,7 +13186,7 @@
               </a:defRPr>
             </a:pPr>
             <a:r>
-              <a:rPr>
+              <a:rPr dirty="0">
                 <a:ea typeface="Microsoft JhengHei"/>
               </a:rPr>
               <a:t>attests</a:t>
@@ -13300,13 +13197,15 @@
       <p:cxnSp>
         <p:nvCxnSpPr>
           <p:cNvPr id="18" name="Connector 17"/>
-          <p:cNvCxnSpPr/>
+          <p:cNvCxnSpPr>
+            <a:cxnSpLocks/>
+          </p:cNvCxnSpPr>
           <p:nvPr/>
         </p:nvCxnSpPr>
         <p:spPr>
           <a:xfrm flipV="1">
-            <a:off x="6334125" y="3381376"/>
-            <a:ext cx="1524000" cy="1047749"/>
+            <a:off x="6334125" y="3057525"/>
+            <a:ext cx="1857375" cy="1371600"/>
           </a:xfrm>
           <a:prstGeom prst="line">
             <a:avLst/>
@@ -13341,8 +13240,8 @@
         </p:nvSpPr>
         <p:spPr>
           <a:xfrm>
-            <a:off x="6477000" y="4629150"/>
-            <a:ext cx="1905000" cy="333375"/>
+            <a:off x="6962775" y="4024312"/>
+            <a:ext cx="1905000" cy="586635"/>
           </a:xfrm>
           <a:prstGeom prst="rect">
             <a:avLst/>
@@ -13373,46 +13272,20 @@
               </a:defRPr>
             </a:pPr>
             <a:r>
-              <a:rPr>
+              <a:rPr dirty="0">
                 <a:ea typeface="Microsoft JhengHei"/>
               </a:rPr>
               <a:t>searched for</a:t>
             </a:r>
-          </a:p>
-        </p:txBody>
-      </p:sp>
-      <p:sp>
-        <p:nvSpPr>
-          <p:cNvPr id="20" name="TextBox 19"/>
-          <p:cNvSpPr txBox="1"/>
-          <p:nvPr/>
-        </p:nvSpPr>
-        <p:spPr>
-          <a:xfrm>
-            <a:off x="6477000" y="5000625"/>
-            <a:ext cx="1714500" cy="333375"/>
-          </a:xfrm>
-          <a:prstGeom prst="rect">
-            <a:avLst/>
-          </a:prstGeom>
-          <a:noFill/>
-        </p:spPr>
-        <p:txBody>
-          <a:bodyPr wrap="square" lIns="0" tIns="0" rIns="0" bIns="0">
-            <a:spAutoFit/>
-          </a:bodyPr>
-          <a:lstStyle/>
-          <a:p>
-            <a:pPr>
-              <a:lnSpc>
-                <a:spcPct val="118000"/>
-              </a:lnSpc>
-              <a:spcBef>
-                <a:spcPts val="0"/>
-              </a:spcBef>
-              <a:spcAft>
-                <a:spcPts val="0"/>
-              </a:spcAft>
+            <a:endParaRPr lang="en-US" dirty="0">
+              <a:ea typeface="Microsoft JhengHei"/>
+            </a:endParaRPr>
+          </a:p>
+          <a:p>
+            <a:pPr>
+              <a:lnSpc>
+                <a:spcPct val="118000"/>
+              </a:lnSpc>
               <a:defRPr sz="1700" b="0">
                 <a:solidFill>
                   <a:srgbClr val="65439A"/>
@@ -13421,7 +13294,7 @@
               </a:defRPr>
             </a:pPr>
             <a:r>
-              <a:rPr>
+              <a:rPr lang="en-US" altLang="zh-TW" dirty="0">
                 <a:ea typeface="Microsoft JhengHei"/>
               </a:rPr>
               <a:t>or tests</a:t>
@@ -13437,7 +13310,7 @@
         </p:nvCxnSpPr>
         <p:spPr>
           <a:xfrm>
-            <a:off x="9620250" y="3352800"/>
+            <a:off x="9143999" y="3476625"/>
             <a:ext cx="0" cy="904875"/>
           </a:xfrm>
           <a:prstGeom prst="line">
@@ -13473,7 +13346,7 @@
         </p:nvSpPr>
         <p:spPr>
           <a:xfrm>
-            <a:off x="9906000" y="3638550"/>
+            <a:off x="9334500" y="3643312"/>
             <a:ext cx="1524000" cy="333375"/>
           </a:xfrm>
           <a:prstGeom prst="rect">
@@ -13505,7 +13378,7 @@
               </a:defRPr>
             </a:pPr>
             <a:r>
-              <a:rPr>
+              <a:rPr dirty="0">
                 <a:ea typeface="Microsoft JhengHei"/>
               </a:rPr>
               <a:t>addresses</a:t>
@@ -13521,8 +13394,8 @@
         </p:nvSpPr>
         <p:spPr>
           <a:xfrm>
-            <a:off x="8620125" y="5791200"/>
-            <a:ext cx="2857500" cy="419100"/>
+            <a:off x="7715249" y="5440607"/>
+            <a:ext cx="2857500" cy="310662"/>
           </a:xfrm>
           <a:prstGeom prst="rect">
             <a:avLst/>
@@ -13535,17 +13408,17 @@
           </a:bodyPr>
           <a:lstStyle/>
           <a:p>
-            <a:pPr>
-              <a:lnSpc>
-                <a:spcPct val="118000"/>
-              </a:lnSpc>
-              <a:spcBef>
-                <a:spcPts val="0"/>
-              </a:spcBef>
-              <a:spcAft>
-                <a:spcPts val="0"/>
-              </a:spcAft>
-              <a:defRPr sz="1900" b="1">
+            <a:pPr algn="ctr">
+              <a:lnSpc>
+                <a:spcPct val="118000"/>
+              </a:lnSpc>
+              <a:spcBef>
+                <a:spcPts val="0"/>
+              </a:spcBef>
+              <a:spcAft>
+                <a:spcPts val="0"/>
+              </a:spcAft>
+              <a:defRPr sz="1800" b="1">
                 <a:solidFill>
                   <a:srgbClr val="80511B"/>
                 </a:solidFill>
@@ -13553,84 +13426,14 @@
               </a:defRPr>
             </a:pPr>
             <a:r>
-              <a:rPr>
+              <a:rPr lang="en-US" dirty="0">
                 <a:ea typeface="Microsoft JhengHei"/>
               </a:rPr>
               <a:t>Research question</a:t>
             </a:r>
-          </a:p>
-        </p:txBody>
-      </p:sp>
-      <p:sp>
-        <p:nvSpPr>
-          <p:cNvPr id="24" name="TextBox 23"/>
-          <p:cNvSpPr txBox="1"/>
-          <p:nvPr/>
-        </p:nvSpPr>
-        <p:spPr>
-          <a:xfrm>
-            <a:off x="523874" y="5505450"/>
-            <a:ext cx="7524749" cy="714375"/>
-          </a:xfrm>
-          <a:prstGeom prst="rect">
-            <a:avLst/>
-          </a:prstGeom>
-          <a:noFill/>
-        </p:spPr>
-        <p:txBody>
-          <a:bodyPr wrap="square" lIns="0" tIns="0" rIns="0" bIns="0">
-            <a:spAutoFit/>
-          </a:bodyPr>
-          <a:lstStyle/>
-          <a:p>
-            <a:pPr>
-              <a:lnSpc>
-                <a:spcPct val="118000"/>
-              </a:lnSpc>
-              <a:spcBef>
-                <a:spcPts val="0"/>
-              </a:spcBef>
-              <a:spcAft>
-                <a:spcPts val="0"/>
-              </a:spcAft>
-              <a:defRPr sz="2200" b="0">
-                <a:solidFill>
-                  <a:srgbClr val="24384A"/>
-                </a:solidFill>
-                <a:latin typeface="Lato"/>
-              </a:defRPr>
-            </a:pPr>
-            <a:r>
-              <a:rPr>
-                <a:ea typeface="Microsoft JhengHei"/>
-              </a:rPr>
-              <a:t>Arrows show different relationships.</a:t>
-            </a:r>
-          </a:p>
-          <a:p>
-            <a:pPr>
-              <a:lnSpc>
-                <a:spcPct val="118000"/>
-              </a:lnSpc>
-              <a:spcBef>
-                <a:spcPts val="0"/>
-              </a:spcBef>
-              <a:spcAft>
-                <a:spcPts val="0"/>
-              </a:spcAft>
-              <a:defRPr sz="2200" b="0">
-                <a:solidFill>
-                  <a:srgbClr val="24384A"/>
-                </a:solidFill>
-                <a:latin typeface="Lato"/>
-              </a:defRPr>
-            </a:pPr>
-            <a:r>
-              <a:rPr>
-                <a:ea typeface="Microsoft JhengHei"/>
-              </a:rPr>
-              <a:t>A search is not itself a supporting quotation.</a:t>
-            </a:r>
+            <a:endParaRPr dirty="0">
+              <a:ea typeface="Microsoft JhengHei"/>
+            </a:endParaRPr>
           </a:p>
         </p:txBody>
       </p:sp>
@@ -13895,7 +13698,7 @@
               <a:rPr>
                 <a:ea typeface="Microsoft JhengHei"/>
               </a:rPr>
-              <a:t>Why use an evidence graph?</a:t>
+              <a:t>An evidence graph connects proposals to evidence</a:t>
             </a:r>
           </a:p>
         </p:txBody>
@@ -13943,7 +13746,7 @@
               <a:rPr>
                 <a:ea typeface="Microsoft JhengHei"/>
               </a:rPr>
-              <a:t>Trace a proposal</a:t>
+              <a:t>Inspect a proposal</a:t>
             </a:r>
           </a:p>
         </p:txBody>
@@ -13980,7 +13783,7 @@
               <a:spcAft>
                 <a:spcPts val="0"/>
               </a:spcAft>
-              <a:defRPr sz="2400" b="0">
+              <a:defRPr sz="2000" b="0">
                 <a:solidFill>
                   <a:srgbClr val="24384A"/>
                 </a:solidFill>
@@ -13991,7 +13794,7 @@
               <a:rPr>
                 <a:ea typeface="Microsoft JhengHei"/>
               </a:rPr>
-              <a:t>Follow its citations to passages and source records.</a:t>
+              <a:t>Follow a claim or conjecture to its cited passages and source texts. A link does not make the proposal true.</a:t>
             </a:r>
           </a:p>
         </p:txBody>
@@ -14039,7 +13842,7 @@
               <a:rPr>
                 <a:ea typeface="Microsoft JhengHei"/>
               </a:rPr>
-              <a:t>Inspect dependencies</a:t>
+              <a:t>Inspect text relationships</a:t>
             </a:r>
           </a:p>
         </p:txBody>
@@ -14076,7 +13879,7 @@
               <a:spcAft>
                 <a:spcPts val="0"/>
               </a:spcAft>
-              <a:defRPr sz="2400" b="0">
+              <a:defRPr sz="2000" b="0">
                 <a:solidFill>
                   <a:srgbClr val="24384A"/>
                 </a:solidFill>
@@ -14084,10 +13887,10 @@
               </a:defRPr>
             </a:pPr>
             <a:r>
-              <a:rPr>
-                <a:ea typeface="Microsoft JhengHei"/>
-              </a:rPr>
-              <a:t>See recorded quotation, parallel and descent links.</a:t>
+              <a:rPr dirty="0">
+                <a:ea typeface="Microsoft JhengHei"/>
+              </a:rPr>
+              <a:t>Quotation: reproduced wording. Parallel: corresponding passages. Descent: one text or version proposed to derive from another.</a:t>
             </a:r>
           </a:p>
         </p:txBody>
@@ -14101,7 +13904,7 @@
         <p:spPr>
           <a:xfrm>
             <a:off x="523874" y="4000500"/>
-            <a:ext cx="3190875" cy="752475"/>
+            <a:ext cx="3190875" cy="862737"/>
           </a:xfrm>
           <a:prstGeom prst="rect">
             <a:avLst/>
@@ -14132,11 +13935,14 @@
               </a:defRPr>
             </a:pPr>
             <a:r>
-              <a:rPr>
-                <a:ea typeface="Microsoft JhengHei"/>
-              </a:rPr>
-              <a:t>Keep the history</a:t>
-            </a:r>
+              <a:rPr lang="en-US" dirty="0">
+                <a:ea typeface="Microsoft JhengHei"/>
+              </a:rPr>
+              <a:t>Review the record</a:t>
+            </a:r>
+            <a:endParaRPr dirty="0">
+              <a:ea typeface="Microsoft JhengHei"/>
+            </a:endParaRPr>
           </a:p>
         </p:txBody>
       </p:sp>
@@ -14172,7 +13978,7 @@
               <a:spcAft>
                 <a:spcPts val="0"/>
               </a:spcAft>
-              <a:defRPr sz="2400" b="0">
+              <a:defRPr sz="2000" b="0">
                 <a:solidFill>
                   <a:srgbClr val="24384A"/>
                 </a:solidFill>
@@ -14180,10 +13986,10 @@
               </a:defRPr>
             </a:pPr>
             <a:r>
-              <a:rPr>
-                <a:ea typeface="Microsoft JhengHei"/>
-              </a:rPr>
-              <a:t>Who proposed it, what was checked, what the researcher decided.</a:t>
+              <a:rPr dirty="0">
+                <a:ea typeface="Microsoft JhengHei"/>
+              </a:rPr>
+              <a:t>See who proposed it, which citations were checked, and whether the researcher accepted or rejected it.</a:t>
             </a:r>
           </a:p>
         </p:txBody>
@@ -14276,7 +14082,7 @@
               </a:defRPr>
             </a:pPr>
             <a:r>
-              <a:rPr>
+              <a:rPr dirty="0">
                 <a:ea typeface="Microsoft JhengHei"/>
               </a:rPr>
               <a:t>Suggest a quotation or parallel to investigate, with passages to check.</a:t>
@@ -14850,7 +14656,7 @@
               </a:defRPr>
             </a:pPr>
             <a:r>
-              <a:rPr>
+              <a:rPr dirty="0">
                 <a:ea typeface="Microsoft JhengHei"/>
               </a:rPr>
               <a:t>Open a saved proposal</a:t>
@@ -15016,7 +14822,7 @@
               </a:defRPr>
             </a:pPr>
             <a:r>
-              <a:rPr>
+              <a:rPr dirty="0">
                 <a:ea typeface="Microsoft JhengHei"/>
               </a:rPr>
               <a:t>Cited passages</a:t>
@@ -16793,7 +16599,7 @@
               </a:defRPr>
             </a:pPr>
             <a:r>
-              <a:rPr>
+              <a:rPr dirty="0">
                 <a:ea typeface="Microsoft JhengHei"/>
               </a:rPr>
               <a:t>Results and limits</a:t>
@@ -16841,7 +16647,7 @@
               </a:defRPr>
             </a:pPr>
             <a:r>
-              <a:rPr>
+              <a:rPr dirty="0">
                 <a:ea typeface="Microsoft JhengHei"/>
               </a:rPr>
               <a:t>Results and limits</a:t>
@@ -16858,7 +16664,7 @@
         <p:spPr>
           <a:xfrm>
             <a:off x="523874" y="1943100"/>
-            <a:ext cx="5286375" cy="485775"/>
+            <a:ext cx="5286375" cy="392415"/>
           </a:xfrm>
           <a:prstGeom prst="rect">
             <a:avLst/>
@@ -16889,8 +16695,14 @@
               </a:defRPr>
             </a:pPr>
             <a:r>
-              <a:t>What the tools showed</a:t>
-            </a:r>
+              <a:rPr dirty="0"/>
+              <a:t>What the tools </a:t>
+            </a:r>
+            <a:r>
+              <a:rPr lang="en-US" dirty="0"/>
+              <a:t>managed</a:t>
+            </a:r>
+            <a:endParaRPr dirty="0"/>
           </a:p>
         </p:txBody>
       </p:sp>
@@ -16903,7 +16715,7 @@
         <p:spPr>
           <a:xfrm>
             <a:off x="6524625" y="1943100"/>
-            <a:ext cx="5143500" cy="485775"/>
+            <a:ext cx="5143500" cy="392415"/>
           </a:xfrm>
           <a:prstGeom prst="rect">
             <a:avLst/>
@@ -16934,8 +16746,10 @@
               </a:defRPr>
             </a:pPr>
             <a:r>
-              <a:t>What we still need to check</a:t>
-            </a:r>
+              <a:rPr lang="en-US" dirty="0"/>
+              <a:t>Issues and reminders</a:t>
+            </a:r>
+            <a:endParaRPr dirty="0"/>
           </a:p>
         </p:txBody>
       </p:sp>
@@ -17024,7 +16838,40 @@
               </a:defRPr>
             </a:pPr>
             <a:r>
-              <a:t>T0262 Lotus: known translator Kumārajīva 鳩摩羅什; vocabulary ranks Dharmakṣema 曇無讖 first.</a:t>
+              <a:rPr dirty="0"/>
+              <a:t>T0262 Lotus: known translator </a:t>
+            </a:r>
+            <a:r>
+              <a:rPr dirty="0" err="1"/>
+              <a:t>Kumārajīva</a:t>
+            </a:r>
+            <a:r>
+              <a:rPr dirty="0"/>
+              <a:t> </a:t>
+            </a:r>
+            <a:r>
+              <a:rPr dirty="0" err="1"/>
+              <a:t>鳩摩羅什</a:t>
+            </a:r>
+            <a:r>
+              <a:rPr dirty="0"/>
+              <a:t>; vocabulary ranks </a:t>
+            </a:r>
+            <a:r>
+              <a:rPr dirty="0" err="1"/>
+              <a:t>Dharmakṣema</a:t>
+            </a:r>
+            <a:r>
+              <a:rPr dirty="0"/>
+              <a:t> </a:t>
+            </a:r>
+            <a:r>
+              <a:rPr dirty="0" err="1"/>
+              <a:t>曇無讖</a:t>
+            </a:r>
+            <a:r>
+              <a:rPr dirty="0"/>
+              <a:t> first.</a:t>
             </a:r>
           </a:p>
         </p:txBody>
@@ -17159,6 +17006,7 @@
               </a:defRPr>
             </a:pPr>
             <a:r>
+              <a:rPr dirty="0"/>
               <a:t>The graph brings proposals, cited passages and recorded checks together.</a:t>
             </a:r>
           </a:p>
@@ -19941,7 +19789,7 @@
               <a:rPr lang="en-US" dirty="0">
                 <a:ea typeface="Microsoft JhengHei"/>
               </a:rPr>
-              <a:t>Using known  </a:t>
+              <a:t>Using known questions lets us know how the tool performs </a:t>
             </a:r>
             <a:endParaRPr dirty="0">
               <a:ea typeface="Microsoft JhengHei"/>

</xml_diff>

<commit_message>
Add Chinese translator names to slides and speaker notes
</commit_message>
<xml_diff>
--- a/docs/presentation/cohort-pnc-2026-main.pptx
+++ b/docs/presentation/cohort-pnc-2026-main.pptx
@@ -1056,7 +1056,7 @@
           </a:p>
           <a:p>
             <a:r>
-              <a:t>This calculation illustrates a historical-dependence problem: the later commentary contains wording from the earlier text, but belongs to another reference group. Excluding it makes An Shigao the top-ranked group, matching the accepted attribution, by a small uncalibrated margin. It is one known-answer check, not evidence of reliable attribution on unknown texts.</a:t>
+              <a:t>This calculation illustrates a historical-dependence problem: the later commentary contains wording from the earlier text, but belongs to another reference group. Excluding it makes An Shigao 安世高 the top-ranked group, matching the accepted attribution, by a small uncalibrated margin. It is one known-answer check, not evidence of reliable attribution on unknown texts.</a:t>
             </a:r>
           </a:p>
           <a:p>
@@ -1064,7 +1064,7 @@
           </a:p>
           <a:p>
             <a:r>
-              <a:t>T1694 is assigned to the mixed pre-Dharmarakṣa group. Its shared wording contributes to that group’s profile. Removing it changes the reference profile, not T0603. An Shigao worked in the second century CE; Dharmarakṣa later, in the late third and early fourth centuries. “Before Dharmarakṣa” is a catalogue category, not his own work.</a:t>
+              <a:t>T1694 is assigned to the mixed pre-Dharmarakṣa 竺法護 group. Its shared wording contributes to that group’s profile. Removing it changes the reference profile, not T0603. An Shigao 安世高 worked in the second century CE; Dharmarakṣa 竺法護 later, in the late third and early fourth centuries. “Before Dharmarakṣa 竺法護” is a catalogue category, not his own work.</a:t>
             </a:r>
           </a:p>
           <a:p>
@@ -1119,7 +1119,7 @@
           </a:p>
           <a:p>
             <a:r>
-              <a:t>T1694 contributes to the mixed group in the first row. “Other material before Dharmarakṣa” is a catalogue category for early material, not one competing translator. Excluding the commentary changes the leader and greatly reduces the lead.</a:t>
+              <a:t>T1694 contributes to the mixed group in the first row. “Other material before Dharmarakṣa 竺法護” is a catalogue category for early material, not one competing translator. Excluding the commentary changes the leader and greatly reduces the lead.</a:t>
             </a:r>
           </a:p>
           <a:p>
@@ -1143,7 +1143,7 @@
           </a:p>
           <a:p>
             <a:r>
-              <a:t>Do not translate 0.096 into a probability or call it a statistically established tie. An Shigao’s new first place does not establish his authorship. The comparison does not determine which text borrowed from which.</a:t>
+              <a:t>Do not translate 0.096 into a probability or call it a statistically established tie. An Shigao 安世高’s new first place does not establish his authorship. The comparison does not determine which text borrowed from which.</a:t>
             </a:r>
           </a:p>
           <a:p>
@@ -1159,7 +1159,7 @@
           </a:p>
           <a:p>
             <a:r>
-              <a:t>An Shigao worked in the second century CE. Dharmarakṣa worked in the late third and early fourth centuries. The pre-Dharmarakṣa group is an inherited catalogue category; T1694 belongs to it in the supplied data. This label does not settle the debated date or authorship of the commentary. Explain the chronological ordering without attempting to date every group.</a:t>
+              <a:t>An Shigao 安世高 worked in the second century CE. Dharmarakṣa 竺法護 worked in the late third and early fourth centuries. The pre-Dharmarakṣa 竺法護 group is an inherited catalogue category; T1694 belongs to it in the supplied data. This label does not settle the debated date or authorship of the commentary. Explain the chronological ordering without attempting to date every group.</a:t>
             </a:r>
           </a:p>
         </p:txBody>
@@ -2358,7 +2358,7 @@
           </a:p>
           <a:p>
             <a:r>
-              <a:t>Radich supplied the research corpus derived from CBETA, its working catalogue labels, and the short-string list assembled for Dharmarakṣa vocabulary research. Cohort computes profiles, rankings, alignments and embedding retrieval results. Do not attribute those computed results to him.</a:t>
+              <a:t>Radich supplied the research corpus derived from CBETA, its working catalogue labels, and the short-string list assembled for Dharmarakṣa 竺法護 vocabulary research. Cohort computes profiles, rankings, alignments and embedding retrieval results. Do not attribute those computed results to him.</a:t>
             </a:r>
           </a:p>
         </p:txBody>
@@ -2462,7 +2462,7 @@
           </a:p>
           <a:p>
             <a:r>
-              <a:t>The first count concerns T0263-rest and T0262-exDevadatta, not every passage in complete editions. Nearest means first under vector similarity among indexed other works. This is an illustrative case selected after inspecting outputs, not a retrieval accuracy benchmark. Vocabulary excludes the target’s entire Taishō work, but other dependence and genre effects remain. Reverse control: T0262-exDevadatta ranks with Dharmakṣema under both vocabularies, not its catalogue label Kumārajīva. Mention that failure verbally: agreement for one example does not validate attribution. Measurements: scripts/check_method_examples.py; docs/presentation/method-examples.json.</a:t>
+              <a:t>The first count concerns T0263-rest and T0262-exDevadatta, not every passage in complete editions. Nearest means first under vector similarity among indexed other works. This is an illustrative case selected after inspecting outputs, not a retrieval accuracy benchmark. Vocabulary excludes the target’s entire Taishō work, but other dependence and genre effects remain. Reverse control: T0262-exDevadatta ranks with Dharmakṣema 曇無讖 under both vocabularies, not its catalogue label Kumārajīva 鳩摩羅什. Mention that failure verbally: agreement for one example does not validate attribution. Measurements: scripts/check_method_examples.py; docs/presentation/method-examples.json.</a:t>
             </a:r>
           </a:p>
           <a:p>
@@ -2857,7 +2857,7 @@
           </a:p>
           <a:p>
             <a:r>
-              <a:t>T0603 is traditionally associated with An Shigao. We are checking a known case, not attributing an unknown text. Dates and the commentary relationship come from scholarship.</a:t>
+              <a:t>T0603 is traditionally associated with An Shigao 安世高. We are checking a known case, not attributing an unknown text. Dates and the commentary relationship come from scholarship.</a:t>
             </a:r>
           </a:p>
         </p:txBody>
@@ -3523,7 +3523,7 @@
             </a:r>
             <a:r>
               <a:rPr dirty="0" err="1"/>
-              <a:t>Dharmakṣema</a:t>
+              <a:t>Dharmakṣema 曇無讖</a:t>
             </a:r>
             <a:r>
               <a:rPr dirty="0"/>
@@ -3531,7 +3531,7 @@
             </a:r>
             <a:r>
               <a:rPr dirty="0" err="1"/>
-              <a:t>Kumārajīva</a:t>
+              <a:t>Kumārajīva 鳩摩羅什</a:t>
             </a:r>
             <a:r>
               <a:rPr dirty="0"/>
@@ -16384,7 +16384,7 @@
               <a:rPr>
                 <a:ea typeface="Microsoft JhengHei"/>
               </a:rPr>
-              <a:t>Dharmarakṣa research</a:t>
+              <a:t>Dharmarakṣa 竺法護 research</a:t>
             </a:r>
           </a:p>
         </p:txBody>
@@ -21890,7 +21890,7 @@
               <a:rPr>
                 <a:ea typeface="Microsoft JhengHei"/>
               </a:rPr>
-              <a:t>Dharmarakṣa · T0263-rest</a:t>
+              <a:t>Dharmarakṣa 竺法護 · T0263-rest</a:t>
             </a:r>
           </a:p>
           <a:p>
@@ -22011,7 +22011,7 @@
               <a:rPr>
                 <a:ea typeface="Microsoft JhengHei"/>
               </a:rPr>
-              <a:t>Kumārajīva · T0262-exDevadatta</a:t>
+              <a:t>Kumārajīva 鳩摩羅什 · T0262-exDevadatta</a:t>
             </a:r>
           </a:p>
           <a:p>

</xml_diff>